<commit_message>
Prepare for Cloud run deployment
</commit_message>
<xml_diff>
--- a/assets/Template_Autoconocimiento 2.0 (counseling).pptx
+++ b/assets/Template_Autoconocimiento 2.0 (counseling).pptx
@@ -323,10 +323,49 @@
   <pc:docChgLst>
     <pc:chgData name="juani vila bach" userId="140d79d91c36b714" providerId="LiveId" clId="{681BBBA0-CB6B-4408-8383-25A2ECA50787}"/>
     <pc:docChg chg="modSld">
-      <pc:chgData name="juani vila bach" userId="140d79d91c36b714" providerId="LiveId" clId="{681BBBA0-CB6B-4408-8383-25A2ECA50787}" dt="2025-12-22T14:47:05.044" v="0" actId="20577"/>
+      <pc:chgData name="juani vila bach" userId="140d79d91c36b714" providerId="LiveId" clId="{681BBBA0-CB6B-4408-8383-25A2ECA50787}" dt="2025-12-28T06:01:44.568" v="1" actId="255"/>
       <pc:docMkLst>
         <pc:docMk/>
       </pc:docMkLst>
+      <pc:sldChg chg="modSp mod">
+        <pc:chgData name="juani vila bach" userId="140d79d91c36b714" providerId="LiveId" clId="{681BBBA0-CB6B-4408-8383-25A2ECA50787}" dt="2025-12-28T06:01:44.568" v="1" actId="255"/>
+        <pc:sldMkLst>
+          <pc:docMk/>
+          <pc:sldMk cId="0" sldId="260"/>
+        </pc:sldMkLst>
+        <pc:spChg chg="mod">
+          <ac:chgData name="juani vila bach" userId="140d79d91c36b714" providerId="LiveId" clId="{681BBBA0-CB6B-4408-8383-25A2ECA50787}" dt="2025-12-28T06:01:44.568" v="1" actId="255"/>
+          <ac:spMkLst>
+            <pc:docMk/>
+            <pc:sldMk cId="0" sldId="260"/>
+            <ac:spMk id="95" creationId="{00000000-0000-0000-0000-000000000000}"/>
+          </ac:spMkLst>
+        </pc:spChg>
+        <pc:spChg chg="mod">
+          <ac:chgData name="juani vila bach" userId="140d79d91c36b714" providerId="LiveId" clId="{681BBBA0-CB6B-4408-8383-25A2ECA50787}" dt="2025-12-28T06:01:44.568" v="1" actId="255"/>
+          <ac:spMkLst>
+            <pc:docMk/>
+            <pc:sldMk cId="0" sldId="260"/>
+            <ac:spMk id="96" creationId="{00000000-0000-0000-0000-000000000000}"/>
+          </ac:spMkLst>
+        </pc:spChg>
+        <pc:spChg chg="mod">
+          <ac:chgData name="juani vila bach" userId="140d79d91c36b714" providerId="LiveId" clId="{681BBBA0-CB6B-4408-8383-25A2ECA50787}" dt="2025-12-28T06:01:44.568" v="1" actId="255"/>
+          <ac:spMkLst>
+            <pc:docMk/>
+            <pc:sldMk cId="0" sldId="260"/>
+            <ac:spMk id="97" creationId="{00000000-0000-0000-0000-000000000000}"/>
+          </ac:spMkLst>
+        </pc:spChg>
+        <pc:spChg chg="mod">
+          <ac:chgData name="juani vila bach" userId="140d79d91c36b714" providerId="LiveId" clId="{681BBBA0-CB6B-4408-8383-25A2ECA50787}" dt="2025-12-28T06:01:44.568" v="1" actId="255"/>
+          <ac:spMkLst>
+            <pc:docMk/>
+            <pc:sldMk cId="0" sldId="260"/>
+            <ac:spMk id="98" creationId="{00000000-0000-0000-0000-000000000000}"/>
+          </ac:spMkLst>
+        </pc:spChg>
+      </pc:sldChg>
       <pc:sldChg chg="modSp mod">
         <pc:chgData name="juani vila bach" userId="140d79d91c36b714" providerId="LiveId" clId="{681BBBA0-CB6B-4408-8383-25A2ECA50787}" dt="2025-12-22T14:47:05.044" v="0" actId="20577"/>
         <pc:sldMkLst>
@@ -3521,8 +3560,8 @@
         </p:nvSpPr>
         <p:spPr>
           <a:xfrm>
-            <a:off x="2464919" y="685800"/>
-            <a:ext cx="1928700" cy="3429000"/>
+            <a:off x="2465388" y="685800"/>
+            <a:ext cx="1928812" cy="3429000"/>
           </a:xfrm>
           <a:custGeom>
             <a:avLst/>
@@ -16061,7 +16100,7 @@
               <a:buNone/>
             </a:pPr>
             <a:r>
-              <a:rPr lang="en" sz="2200" b="1">
+              <a:rPr lang="en" sz="2500" b="1" dirty="0">
                 <a:solidFill>
                   <a:schemeClr val="dk1"/>
                 </a:solidFill>
@@ -16072,7 +16111,7 @@
               </a:rPr>
               <a:t>&lt;&lt;Carrera 03&gt;&gt;</a:t>
             </a:r>
-            <a:endParaRPr sz="2200" b="1">
+            <a:endParaRPr sz="2500" b="1" dirty="0">
               <a:solidFill>
                 <a:schemeClr val="dk1"/>
               </a:solidFill>
@@ -16119,7 +16158,7 @@
               <a:buNone/>
             </a:pPr>
             <a:r>
-              <a:rPr lang="en" sz="2200" b="1">
+              <a:rPr lang="en" sz="2500" b="1">
                 <a:solidFill>
                   <a:schemeClr val="dk1"/>
                 </a:solidFill>
@@ -16130,7 +16169,7 @@
               </a:rPr>
               <a:t>&lt;&lt;Carrera 04&gt;&gt;</a:t>
             </a:r>
-            <a:endParaRPr sz="2200" b="1">
+            <a:endParaRPr sz="2500" b="1">
               <a:solidFill>
                 <a:schemeClr val="dk1"/>
               </a:solidFill>
@@ -16177,7 +16216,7 @@
               <a:buNone/>
             </a:pPr>
             <a:r>
-              <a:rPr lang="en" sz="2200" b="1">
+              <a:rPr lang="en" sz="2500" b="1">
                 <a:solidFill>
                   <a:schemeClr val="dk1"/>
                 </a:solidFill>
@@ -16188,7 +16227,7 @@
               </a:rPr>
               <a:t>&lt;&lt;Carrera 01&gt;&gt;</a:t>
             </a:r>
-            <a:endParaRPr sz="2200" b="1">
+            <a:endParaRPr sz="2500" b="1">
               <a:solidFill>
                 <a:schemeClr val="dk1"/>
               </a:solidFill>
@@ -16235,7 +16274,7 @@
               <a:buNone/>
             </a:pPr>
             <a:r>
-              <a:rPr lang="en" sz="2200" b="1">
+              <a:rPr lang="en" sz="2500" b="1">
                 <a:solidFill>
                   <a:schemeClr val="dk1"/>
                 </a:solidFill>
@@ -16246,7 +16285,7 @@
               </a:rPr>
               <a:t>&lt;&lt;Carrera 02&gt;&gt;</a:t>
             </a:r>
-            <a:endParaRPr sz="2200" b="1">
+            <a:endParaRPr sz="2500" b="1">
               <a:solidFill>
                 <a:schemeClr val="dk1"/>
               </a:solidFill>

</xml_diff>